<commit_message>
Restructure background to 5-step logic; add LMCache as DP1 candidate 3
배경 문서(v2)·덱을 새 ①~⑤ 논리로 재구성:
- 배경1: ①병목 심화 → ②업계의 메모리 중심 해법 → ③자사 두 방향 제품군 보유
- 배경2: ④현재 런타임의 한계(vLLM 단일 메모리 가정 + LMCache 등 KV 계층의
  commodity 백엔드/근접연산 부재) → ⑤자사 제품군을 활용하는 MCR 개발 필요
- 신규 그림 nec_kvlayer.png (KV 계층은 있으나 메모리는 수동 백엔드)

DP 문서(v0.3): DP1에 후보구조 3 'KV-계층(LMCache) 확장형' 추가
- 문제 정의에 KV-계층 생태계 선점 압력 보강, 설계 쟁점 4(DP2·DP6 커플링) 신설
- 구조/장점/단점/QA 평가표(00 v0.3 bin 기준), 검토 노트 3후보 구도 재작성
- 의존성 표에 DP1→DP2 제약 강화, DP1→DP6 행 추가

Co-Authored-By: Claude Fable 5 <noreply@anthropic.com>
Claude-Session: https://claude.ai/code/session_01SAvMt6HX1GPpX8DbB6n1c9
</commit_message>
<xml_diff>
--- a/docs/mcr_background_2p.pptx
+++ b/docs/mcr_background_2p.pptx
@@ -1890,7 +1890,7 @@
                 <a:ea typeface="Malgun Gothic" pitchFamily="34" charset="-122"/>
                 <a:cs typeface="Malgun Gothic" pitchFamily="34" charset="-120"/>
               </a:rPr>
-              <a:t>③ 승부처의 이동: HW → 런타임</a:t>
+              <a:t>③ 자사: 두 방향 모두 제품군 보유</a:t>
             </a:r>
             <a:endParaRPr lang="en-US" sz="1300" dirty="0"/>
           </a:p>
@@ -1933,7 +1933,7 @@
                 <a:ea typeface="Malgun Gothic" pitchFamily="34" charset="-122"/>
                 <a:cs typeface="Malgun Gothic" pitchFamily="34" charset="-120"/>
               </a:rPr>
-              <a:t>해법이 만든 결정 문제: 연산 배치 × 데이터 배치가 결합 — tier·디바이스 늘수록 조합 폭증, 오결정 시 baseline보다 악화</a:t>
+              <a:t>근접 연산(PIM·CIM)부터 계층화(Custom HBM·HBF·CXL)까지 — ②의 두 방향 모두 제품 포트폴리오로 확보</a:t>
             </a:r>
             <a:endParaRPr lang="en-US" sz="1100" dirty="0"/>
           </a:p>
@@ -1941,7 +1941,7 @@
       </p:sp>
       <p:pic>
         <p:nvPicPr>
-          <p:cNvPr id="34" name="Image 4" descr="/home/user/architect/docs/mcr_assets/bg_decision.png">    </p:cNvPr>
+          <p:cNvPr id="34" name="Image 4" descr="/home/user/architect/docs/mcr_assets/bg_devices.png">    </p:cNvPr>
           <p:cNvPicPr>
             <a:picLocks noChangeAspect="1"/>
           </p:cNvPicPr>
@@ -1999,7 +1999,7 @@
                 <a:ea typeface="Malgun Gothic" pitchFamily="34" charset="-122"/>
                 <a:cs typeface="Malgun Gothic" pitchFamily="34" charset="-120"/>
               </a:rPr>
-              <a:t>실증: 동일 HW에서 런타임 교체만으로 KV 낭비 60–80%→&lt;4%·처리량 2–4×(vLLM, SOSP'23), offloading 정책 따라 최대 100×(FlexGen, ICML'23)</a:t>
+              <a:t>근접연산·대역폭·용량의 상이한 축 — 조합 시 새 설계 공간, 병목을 풀 하드웨어 재료는 갖춰짐</a:t>
             </a:r>
             <a:endParaRPr lang="en-US" sz="1100" dirty="0"/>
           </a:p>
@@ -2007,7 +2007,7 @@
       </p:sp>
       <p:pic>
         <p:nvPicPr>
-          <p:cNvPr id="36" name="Image 5" descr="/home/user/architect/docs/mcr_assets/bg_gap.png">    </p:cNvPr>
+          <p:cNvPr id="36" name="Image 5" descr="/home/user/architect/docs/mcr_assets/bg_axes.png">    </p:cNvPr>
           <p:cNvPicPr>
             <a:picLocks noChangeAspect="1"/>
           </p:cNvPicPr>
@@ -2560,7 +2560,7 @@
         <p:spPr>
           <a:xfrm>
             <a:off x="320040" y="1078992"/>
-            <a:ext cx="3716426" cy="310896"/>
+            <a:ext cx="5675224" cy="310896"/>
           </a:xfrm>
           <a:prstGeom prst="rect">
             <a:avLst/>
@@ -2580,7 +2580,7 @@
         <p:spPr>
           <a:xfrm>
             <a:off x="365760" y="1078992"/>
-            <a:ext cx="3624986" cy="310896"/>
+            <a:ext cx="5583784" cy="310896"/>
           </a:xfrm>
           <a:prstGeom prst="rect">
             <a:avLst/>
@@ -2604,7 +2604,7 @@
                 <a:ea typeface="Malgun Gothic" pitchFamily="34" charset="-122"/>
                 <a:cs typeface="Malgun Gothic" pitchFamily="34" charset="-120"/>
               </a:rPr>
-              <a:t>④ 자사: 해법의 재료 보유</a:t>
+              <a:t>④ 현재 런타임은 이 재료를 활용하지 못한다</a:t>
             </a:r>
             <a:endParaRPr lang="en-US" sz="1300" dirty="0"/>
           </a:p>
@@ -2619,7 +2619,7 @@
         <p:spPr>
           <a:xfrm>
             <a:off x="365760" y="1527048"/>
-            <a:ext cx="3624986" cy="713232"/>
+            <a:ext cx="5583784" cy="713232"/>
           </a:xfrm>
           <a:prstGeom prst="rect">
             <a:avLst/>
@@ -2647,7 +2647,7 @@
                 <a:ea typeface="Malgun Gothic" pitchFamily="34" charset="-122"/>
                 <a:cs typeface="Malgun Gothic" pitchFamily="34" charset="-120"/>
               </a:rPr>
-              <a:t>근접 연산(PIM·CIM)부터 계층화(CXL·tiered memory)까지 — ②의 두 방향 모두 제품 포트폴리오로 확보</a:t>
+              <a:t>GPU 중심 설계: 'KV=HBM' 단일 메모리 가정 — 메모리 관리·offloading 정책만으로 성능 2–4×~100× 격차 실증(vLLM SOSP'23 · FlexGen ICML'23)</a:t>
             </a:r>
             <a:endParaRPr lang="en-US" sz="1100" dirty="0"/>
           </a:p>
@@ -2655,7 +2655,7 @@
       </p:sp>
       <p:pic>
         <p:nvPicPr>
-          <p:cNvPr id="22" name="Image 0" descr="/home/user/architect/docs/mcr_assets/bg_devices.png">    </p:cNvPr>
+          <p:cNvPr id="22" name="Image 0" descr="/home/user/architect/docs/mcr_assets/bg_gap.png">    </p:cNvPr>
           <p:cNvPicPr>
             <a:picLocks noChangeAspect="1"/>
           </p:cNvPicPr>
@@ -2669,7 +2669,7 @@
         <p:spPr>
           <a:xfrm>
             <a:off x="320040" y="2286000"/>
-            <a:ext cx="3716426" cy="1618488"/>
+            <a:ext cx="5675224" cy="1618488"/>
           </a:xfrm>
           <a:prstGeom prst="rect">
             <a:avLst/>
@@ -2685,7 +2685,7 @@
         <p:spPr>
           <a:xfrm>
             <a:off x="365760" y="4069080"/>
-            <a:ext cx="3624986" cy="713232"/>
+            <a:ext cx="5583784" cy="713232"/>
           </a:xfrm>
           <a:prstGeom prst="rect">
             <a:avLst/>
@@ -2713,7 +2713,7 @@
                 <a:ea typeface="Malgun Gothic" pitchFamily="34" charset="-122"/>
                 <a:cs typeface="Malgun Gothic" pitchFamily="34" charset="-120"/>
               </a:rPr>
-              <a:t>근접연산·대역폭·용량의 상이한 축 — 조합 시 GPU HBM 단일 체계로 불가능한 설계 공간</a:t>
+              <a:t>KV를 밖으로 내리는 계층(LMCache 등)도 CPU RAM·SSD 등 commodity 저장소의 수동 백엔드 — 디바이스 특성 인지 배치·근접 연산 없음</a:t>
             </a:r>
             <a:endParaRPr lang="en-US" sz="1100" dirty="0"/>
           </a:p>
@@ -2721,7 +2721,7 @@
       </p:sp>
       <p:pic>
         <p:nvPicPr>
-          <p:cNvPr id="24" name="Image 1" descr="/home/user/architect/docs/mcr_assets/bg_axes.png">    </p:cNvPr>
+          <p:cNvPr id="24" name="Image 1" descr="/home/user/architect/docs/mcr_assets/nec_kvlayer.png">    </p:cNvPr>
           <p:cNvPicPr>
             <a:picLocks noChangeAspect="1"/>
           </p:cNvPicPr>
@@ -2735,7 +2735,7 @@
         <p:spPr>
           <a:xfrm>
             <a:off x="320040" y="4828032"/>
-            <a:ext cx="3716426" cy="1618488"/>
+            <a:ext cx="5675224" cy="1618488"/>
           </a:xfrm>
           <a:prstGeom prst="rect">
             <a:avLst/>
@@ -2750,8 +2750,8 @@
         </p:nvSpPr>
         <p:spPr>
           <a:xfrm>
-            <a:off x="4237634" y="1078992"/>
-            <a:ext cx="3716426" cy="310896"/>
+            <a:off x="6196432" y="1078992"/>
+            <a:ext cx="5675224" cy="310896"/>
           </a:xfrm>
           <a:prstGeom prst="rect">
             <a:avLst/>
@@ -2770,8 +2770,8 @@
         </p:nvSpPr>
         <p:spPr>
           <a:xfrm>
-            <a:off x="4283354" y="1078992"/>
-            <a:ext cx="3624986" cy="310896"/>
+            <a:off x="6242152" y="1078992"/>
+            <a:ext cx="5583784" cy="310896"/>
           </a:xfrm>
           <a:prstGeom prst="rect">
             <a:avLst/>
@@ -2795,7 +2795,7 @@
                 <a:ea typeface="Malgun Gothic" pitchFamily="34" charset="-122"/>
                 <a:cs typeface="Malgun Gothic" pitchFamily="34" charset="-120"/>
               </a:rPr>
-              <a:t>⑤ 그러나: 실현 계층의 공백</a:t>
+              <a:t>⑤ 자사 제품군을 활용하는 런타임 개발 필요</a:t>
             </a:r>
             <a:endParaRPr lang="en-US" sz="1300" dirty="0"/>
           </a:p>
@@ -2809,8 +2809,8 @@
         </p:nvSpPr>
         <p:spPr>
           <a:xfrm>
-            <a:off x="4283354" y="1527048"/>
-            <a:ext cx="3624986" cy="713232"/>
+            <a:off x="6242152" y="1527048"/>
+            <a:ext cx="5583784" cy="713232"/>
           </a:xfrm>
           <a:prstGeom prst="rect">
             <a:avLst/>
@@ -2838,7 +2838,7 @@
                 <a:ea typeface="Malgun Gothic" pitchFamily="34" charset="-122"/>
                 <a:cs typeface="Malgun Gothic" pitchFamily="34" charset="-120"/>
               </a:rPr>
-              <a:t>디바이스 가치는 단품 스펙이 아니라 응용(LLM 추론) E2E 성능으로만 실현·입증됨 (←③)</a:t>
+              <a:t>자사 포트폴리오를 1급 자원으로 — 데이터 배치·이동·압축·재사용과 연산 배치를 SLO 기준 조율하는 MCR(Memory-Centric Runtime)</a:t>
             </a:r>
             <a:endParaRPr lang="en-US" sz="1100" dirty="0"/>
           </a:p>
@@ -2846,7 +2846,7 @@
       </p:sp>
       <p:pic>
         <p:nvPicPr>
-          <p:cNvPr id="28" name="Image 2" descr="/home/user/architect/docs/mcr_assets/nec_missing.png">    </p:cNvPr>
+          <p:cNvPr id="28" name="Image 2" descr="/home/user/architect/docs/mcr_assets/nec_arch.png">    </p:cNvPr>
           <p:cNvPicPr>
             <a:picLocks noChangeAspect="1"/>
           </p:cNvPicPr>
@@ -2859,8 +2859,8 @@
         </p:blipFill>
         <p:spPr>
           <a:xfrm>
-            <a:off x="4237634" y="2286000"/>
-            <a:ext cx="3716426" cy="1618488"/>
+            <a:off x="6196432" y="2286000"/>
+            <a:ext cx="5675224" cy="1618488"/>
           </a:xfrm>
           <a:prstGeom prst="rect">
             <a:avLst/>
@@ -2875,199 +2875,8 @@
         </p:nvSpPr>
         <p:spPr>
           <a:xfrm>
-            <a:off x="4283354" y="4069080"/>
-            <a:ext cx="3624986" cy="713232"/>
-          </a:xfrm>
-          <a:prstGeom prst="rect">
-            <a:avLst/>
-          </a:prstGeom>
-          <a:noFill/>
-          <a:ln/>
-        </p:spPr>
-        <p:txBody>
-          <a:bodyPr wrap="square" lIns="0" tIns="0" rIns="0" bIns="0" rtlCol="0" anchor="t"/>
-          <a:lstStyle/>
-          <a:p>
-            <a:pPr algn="l" marL="177800" indent="-177800">
-              <a:spcAft>
-                <a:spcPts val="600"/>
-              </a:spcAft>
-              <a:buSzPct val="100000"/>
-              <a:buChar char="◆"/>
-            </a:pPr>
-            <a:r>
-              <a:rPr lang="en-US" sz="1100" dirty="0">
-                <a:solidFill>
-                  <a:srgbClr val="262626"/>
-                </a:solidFill>
-                <a:latin typeface="Malgun Gothic" pitchFamily="34" charset="0"/>
-                <a:ea typeface="Malgun Gothic" pitchFamily="34" charset="-122"/>
-                <a:cs typeface="Malgun Gothic" pitchFamily="34" charset="-120"/>
-              </a:rPr>
-              <a:t>단품 데모는 있어도, 포트폴리오를 응용과 연결해 시스템 관점 E2E 성능을 증명할 레퍼런스 SW 스택 부재</a:t>
-            </a:r>
-            <a:endParaRPr lang="en-US" sz="1100" dirty="0"/>
-          </a:p>
-        </p:txBody>
-      </p:sp>
-      <p:pic>
-        <p:nvPicPr>
-          <p:cNvPr id="30" name="Image 3" descr="/home/user/architect/docs/mcr_assets/nec_demos.png">    </p:cNvPr>
-          <p:cNvPicPr>
-            <a:picLocks noChangeAspect="1"/>
-          </p:cNvPicPr>
-          <p:nvPr/>
-        </p:nvPicPr>
-        <p:blipFill>
-          <a:blip r:embed="rId4"/>
-          <a:srcRect l="0" r="0" t="0" b="0"/>
-          <a:stretch/>
-        </p:blipFill>
-        <p:spPr>
-          <a:xfrm>
-            <a:off x="4237634" y="4828032"/>
-            <a:ext cx="3716426" cy="1618488"/>
-          </a:xfrm>
-          <a:prstGeom prst="rect">
-            <a:avLst/>
-          </a:prstGeom>
-        </p:spPr>
-      </p:pic>
-      <p:sp>
-        <p:nvSpPr>
-          <p:cNvPr id="31" name="Shape 25"/>
-          <p:cNvSpPr/>
-          <p:nvPr/>
-        </p:nvSpPr>
-        <p:spPr>
-          <a:xfrm>
-            <a:off x="8155229" y="1078992"/>
-            <a:ext cx="3716426" cy="310896"/>
-          </a:xfrm>
-          <a:prstGeom prst="rect">
-            <a:avLst/>
-          </a:prstGeom>
-          <a:solidFill>
-            <a:srgbClr val="4E7C3A"/>
-          </a:solidFill>
-          <a:ln/>
-        </p:spPr>
-      </p:sp>
-      <p:sp>
-        <p:nvSpPr>
-          <p:cNvPr id="32" name="Text 26"/>
-          <p:cNvSpPr/>
-          <p:nvPr/>
-        </p:nvSpPr>
-        <p:spPr>
-          <a:xfrm>
-            <a:off x="8200949" y="1078992"/>
-            <a:ext cx="3624986" cy="310896"/>
-          </a:xfrm>
-          <a:prstGeom prst="rect">
-            <a:avLst/>
-          </a:prstGeom>
-          <a:noFill/>
-          <a:ln/>
-        </p:spPr>
-        <p:txBody>
-          <a:bodyPr wrap="square" lIns="0" tIns="0" rIns="0" bIns="0" rtlCol="0" anchor="ctr"/>
-          <a:lstStyle/>
-          <a:p>
-            <a:pPr algn="ctr" indent="0" marL="0">
-              <a:buNone/>
-            </a:pPr>
-            <a:r>
-              <a:rPr lang="en-US" sz="1300" b="1" dirty="0">
-                <a:solidFill>
-                  <a:srgbClr val="FFFFFF"/>
-                </a:solidFill>
-                <a:latin typeface="Malgun Gothic" pitchFamily="34" charset="0"/>
-                <a:ea typeface="Malgun Gothic" pitchFamily="34" charset="-122"/>
-                <a:cs typeface="Malgun Gothic" pitchFamily="34" charset="-120"/>
-              </a:rPr>
-              <a:t>⑥ 과제: 메모리 중심 런타임 설계</a:t>
-            </a:r>
-            <a:endParaRPr lang="en-US" sz="1300" dirty="0"/>
-          </a:p>
-        </p:txBody>
-      </p:sp>
-      <p:sp>
-        <p:nvSpPr>
-          <p:cNvPr id="33" name="Text 27"/>
-          <p:cNvSpPr/>
-          <p:nvPr/>
-        </p:nvSpPr>
-        <p:spPr>
-          <a:xfrm>
-            <a:off x="8200949" y="1527048"/>
-            <a:ext cx="3624986" cy="713232"/>
-          </a:xfrm>
-          <a:prstGeom prst="rect">
-            <a:avLst/>
-          </a:prstGeom>
-          <a:noFill/>
-          <a:ln/>
-        </p:spPr>
-        <p:txBody>
-          <a:bodyPr wrap="square" lIns="0" tIns="0" rIns="0" bIns="0" rtlCol="0" anchor="t"/>
-          <a:lstStyle/>
-          <a:p>
-            <a:pPr algn="l" marL="177800" indent="-177800">
-              <a:spcAft>
-                <a:spcPts val="600"/>
-              </a:spcAft>
-              <a:buSzPct val="100000"/>
-              <a:buChar char="◆"/>
-            </a:pPr>
-            <a:r>
-              <a:rPr lang="en-US" sz="1100" dirty="0">
-                <a:solidFill>
-                  <a:srgbClr val="262626"/>
-                </a:solidFill>
-                <a:latin typeface="Malgun Gothic" pitchFamily="34" charset="0"/>
-                <a:ea typeface="Malgun Gothic" pitchFamily="34" charset="-122"/>
-                <a:cs typeface="Malgun Gothic" pitchFamily="34" charset="-120"/>
-              </a:rPr>
-              <a:t>자사 포트폴리오를 1급 자원으로 — 배치·이동·압축·재사용을 조율하는 MCR(Memory-Centric Runtime) 설계</a:t>
-            </a:r>
-            <a:endParaRPr lang="en-US" sz="1100" dirty="0"/>
-          </a:p>
-        </p:txBody>
-      </p:sp>
-      <p:pic>
-        <p:nvPicPr>
-          <p:cNvPr id="34" name="Image 4" descr="/home/user/architect/docs/mcr_assets/nec_arch.png">    </p:cNvPr>
-          <p:cNvPicPr>
-            <a:picLocks noChangeAspect="1"/>
-          </p:cNvPicPr>
-          <p:nvPr/>
-        </p:nvPicPr>
-        <p:blipFill>
-          <a:blip r:embed="rId5"/>
-          <a:srcRect l="0" r="0" t="0" b="0"/>
-          <a:stretch/>
-        </p:blipFill>
-        <p:spPr>
-          <a:xfrm>
-            <a:off x="8155229" y="2286000"/>
-            <a:ext cx="3716426" cy="1618488"/>
-          </a:xfrm>
-          <a:prstGeom prst="rect">
-            <a:avLst/>
-          </a:prstGeom>
-        </p:spPr>
-      </p:pic>
-      <p:sp>
-        <p:nvSpPr>
-          <p:cNvPr id="35" name="Text 28"/>
-          <p:cNvSpPr/>
-          <p:nvPr/>
-        </p:nvSpPr>
-        <p:spPr>
-          <a:xfrm>
-            <a:off x="8200949" y="4069080"/>
-            <a:ext cx="3624986" cy="713232"/>
+            <a:off x="6242152" y="4069080"/>
+            <a:ext cx="5583784" cy="713232"/>
           </a:xfrm>
           <a:prstGeom prst="rect">
             <a:avLst/>
@@ -3103,21 +2912,21 @@
       </p:sp>
       <p:pic>
         <p:nvPicPr>
-          <p:cNvPr id="36" name="Image 5" descr="/home/user/architect/docs/mcr_assets/nec_e2e.png">    </p:cNvPr>
+          <p:cNvPr id="30" name="Image 3" descr="/home/user/architect/docs/mcr_assets/nec_e2e.png">    </p:cNvPr>
           <p:cNvPicPr>
             <a:picLocks noChangeAspect="1"/>
           </p:cNvPicPr>
           <p:nvPr/>
         </p:nvPicPr>
         <p:blipFill>
-          <a:blip r:embed="rId6"/>
+          <a:blip r:embed="rId4"/>
           <a:srcRect l="0" r="0" t="0" b="0"/>
           <a:stretch/>
         </p:blipFill>
         <p:spPr>
           <a:xfrm>
-            <a:off x="8155229" y="4828032"/>
-            <a:ext cx="3716426" cy="1618488"/>
+            <a:off x="6196432" y="4828032"/>
+            <a:ext cx="5675224" cy="1618488"/>
           </a:xfrm>
           <a:prstGeom prst="rect">
             <a:avLst/>

</xml_diff>

<commit_message>
evidence-charts: vertical chart, real-photo rule, deck ③·④ visuals
- bg_gap_evidence.png redrawn as vertical column chart (log axis)
- Skill now distinguishes claim types: quantitative -> Excel-style
  chart, product/trend-existence -> real press/product image; added
  image-sourcing section to the playbook (official newsrooms, UA
  fallback for bot-blocked sites, PIL composites, attribution)
- Background deck updated: block ③ now uses SK hynix HBM3E press
  image and a Samsung HBM-PIM + 512GB CXL Expander composite; block
  ④ uses the sourced column chart; ledger extended to cover images

Co-Authored-By: Claude Fable 5 <noreply@anthropic.com>
Claude-Session: https://claude.ai/code/session_01LyTRzLdXE69fgJZWPU6Yf7
</commit_message>
<xml_diff>
--- a/docs/mcr_background_2p.pptx
+++ b/docs/mcr_background_2p.pptx
@@ -1943,7 +1943,7 @@
       </p:sp>
       <p:pic>
         <p:nvPicPr>
-          <p:cNvPr id="34" name="Image 4" descr="/home/user/architect/docs/mcr_assets/bg_hierarchy.png">    </p:cNvPr>
+          <p:cNvPr id="34" name="Image 4" descr="/home/user/architect/docs/mcr_assets/hbm3e_photo.png">    </p:cNvPr>
           <p:cNvPicPr>
             <a:picLocks noChangeAspect="1"/>
           </p:cNvPicPr>
@@ -2009,7 +2009,7 @@
       </p:sp>
       <p:pic>
         <p:nvPicPr>
-          <p:cNvPr id="36" name="Image 5" descr="/home/user/architect/docs/mcr_assets/bg_devices.png">    </p:cNvPr>
+          <p:cNvPr id="36" name="Image 5" descr="/home/user/architect/docs/mcr_assets/samsung_portfolio_photos.png">    </p:cNvPr>
           <p:cNvPicPr>
             <a:picLocks noChangeAspect="1"/>
           </p:cNvPicPr>
@@ -2725,7 +2725,7 @@
       </p:sp>
       <p:pic>
         <p:nvPicPr>
-          <p:cNvPr id="24" name="Image 1" descr="/home/user/architect/docs/mcr_assets/bg_gap.png">    </p:cNvPr>
+          <p:cNvPr id="24" name="Image 1" descr="/home/user/architect/docs/mcr_assets/bg_gap_evidence.png">    </p:cNvPr>
           <p:cNvPicPr>
             <a:picLocks noChangeAspect="1"/>
           </p:cNvPicPr>

</xml_diff>

<commit_message>
Background 1/2: replace ①②'s illustrative charts with sourced ones
- ag_context_evidence: context windows 2K->10M (GPT-3 paper, Claude
  2.1 / Gemini 1.5 / Llama 4 official announcements)
- bg_kv_evidence: KV cache vs context x sessions, derived from the
  Llama-2-70B config (320KB/token) against H100 80GB
- bg_offload_evidence: bandwidth ladder H100 3.35TB/s -> DDR5 x 8ch
  307GB/s -> PM1743 13GB/s
- excelchart: footnote now measures the lowest artist so it clears
  bottom legends; ledger rows added; deck rebuilt (loop diagram in
  ① kept as a structural visual per skill rule)

Co-Authored-By: Claude Fable 5 <noreply@anthropic.com>
Claude-Session: https://claude.ai/code/session_01LyTRzLdXE69fgJZWPU6Yf7
</commit_message>
<xml_diff>
--- a/docs/mcr_background_2p.pptx
+++ b/docs/mcr_background_2p.pptx
@@ -1627,7 +1627,7 @@
       </p:sp>
       <p:pic>
         <p:nvPicPr>
-          <p:cNvPr id="24" name="Image 1" descr="/home/user/architect/docs/mcr_assets/ag_context.png">    </p:cNvPr>
+          <p:cNvPr id="24" name="Image 1" descr="/home/user/architect/docs/mcr_assets/ag_context_evidence.png">    </p:cNvPr>
           <p:cNvPicPr>
             <a:picLocks noChangeAspect="1"/>
           </p:cNvPicPr>
@@ -1752,7 +1752,7 @@
       </p:sp>
       <p:pic>
         <p:nvPicPr>
-          <p:cNvPr id="28" name="Image 2" descr="/home/user/architect/docs/mcr_assets/bg_kv.png">    </p:cNvPr>
+          <p:cNvPr id="28" name="Image 2" descr="/home/user/architect/docs/mcr_assets/bg_kv_evidence.png">    </p:cNvPr>
           <p:cNvPicPr>
             <a:picLocks noChangeAspect="1"/>
           </p:cNvPicPr>
@@ -1818,7 +1818,7 @@
       </p:sp>
       <p:pic>
         <p:nvPicPr>
-          <p:cNvPr id="30" name="Image 3" descr="/home/user/architect/docs/mcr_assets/bg_offload.png">    </p:cNvPr>
+          <p:cNvPr id="30" name="Image 3" descr="/home/user/architect/docs/mcr_assets/bg_offload_evidence.png">    </p:cNvPr>
           <p:cNvPicPr>
             <a:picLocks noChangeAspect="1"/>
           </p:cNvPicPr>

</xml_diff>

<commit_message>
Revert "Background 1/2: replace ①②'s illustrative charts with sourced ones"
This reverts commit 6ed961f256d519e7ac63a0faa7e0deeaf1bfa4e9.
</commit_message>
<xml_diff>
--- a/docs/mcr_background_2p.pptx
+++ b/docs/mcr_background_2p.pptx
@@ -1627,7 +1627,7 @@
       </p:sp>
       <p:pic>
         <p:nvPicPr>
-          <p:cNvPr id="24" name="Image 1" descr="/home/user/architect/docs/mcr_assets/ag_context_evidence.png">    </p:cNvPr>
+          <p:cNvPr id="24" name="Image 1" descr="/home/user/architect/docs/mcr_assets/ag_context.png">    </p:cNvPr>
           <p:cNvPicPr>
             <a:picLocks noChangeAspect="1"/>
           </p:cNvPicPr>
@@ -1752,7 +1752,7 @@
       </p:sp>
       <p:pic>
         <p:nvPicPr>
-          <p:cNvPr id="28" name="Image 2" descr="/home/user/architect/docs/mcr_assets/bg_kv_evidence.png">    </p:cNvPr>
+          <p:cNvPr id="28" name="Image 2" descr="/home/user/architect/docs/mcr_assets/bg_kv.png">    </p:cNvPr>
           <p:cNvPicPr>
             <a:picLocks noChangeAspect="1"/>
           </p:cNvPicPr>
@@ -1818,7 +1818,7 @@
       </p:sp>
       <p:pic>
         <p:nvPicPr>
-          <p:cNvPr id="30" name="Image 3" descr="/home/user/architect/docs/mcr_assets/bg_offload_evidence.png">    </p:cNvPr>
+          <p:cNvPr id="30" name="Image 3" descr="/home/user/architect/docs/mcr_assets/bg_offload.png">    </p:cNvPr>
           <p:cNvPicPr>
             <a:picLocks noChangeAspect="1"/>
           </p:cNvPicPr>

</xml_diff>

<commit_message>
Background 2/2: rework ④ as runtime-stack importance, add subheads
- ④ header renamed to '런타임 스택의 중요도'; top item now argues the
  runtime layer's importance in the AI stack (industry-wide investment:
  TensorRT-LLM, ONNX Runtime, vLLM, SGLang; CUDA moat is software) with
  a new layered-stack diagram highlighting the inference-runtime layer
- pageColumns items support an optional subtitle (bold navy subhead);
  all six items in ④⑤⑥ now carry one

Co-Authored-By: Claude Fable 5 <noreply@anthropic.com>
Claude-Session: https://claude.ai/code/session_01LyTRzLdXE69fgJZWPU6Yf7
</commit_message>
<xml_diff>
--- a/docs/mcr_background_2p.pptx
+++ b/docs/mcr_background_2p.pptx
@@ -2608,7 +2608,7 @@
                 <a:ea typeface="Malgun Gothic" pitchFamily="34" charset="-122"/>
                 <a:cs typeface="Malgun Gothic" pitchFamily="34" charset="-120"/>
               </a:rPr>
-              <a:t>④ 성능은 런타임이 실현한다</a:t>
+              <a:t>④ 런타임 스택의 중요도</a:t>
             </a:r>
             <a:endParaRPr lang="en-US" sz="1300" dirty="0"/>
           </a:p>
@@ -2623,6 +2623,45 @@
         <p:spPr>
           <a:xfrm>
             <a:off x="365760" y="1527048"/>
+            <a:ext cx="3624986" cy="237744"/>
+          </a:xfrm>
+          <a:prstGeom prst="rect">
+            <a:avLst/>
+          </a:prstGeom>
+          <a:noFill/>
+          <a:ln/>
+        </p:spPr>
+        <p:txBody>
+          <a:bodyPr wrap="square" lIns="0" tIns="0" rIns="0" bIns="0" rtlCol="0" anchor="ctr"/>
+          <a:lstStyle/>
+          <a:p>
+            <a:pPr indent="0" marL="0">
+              <a:buNone/>
+            </a:pPr>
+            <a:r>
+              <a:rPr lang="en-US" sz="1200" b="1" dirty="0">
+                <a:solidFill>
+                  <a:srgbClr val="1F3864"/>
+                </a:solidFill>
+                <a:latin typeface="Malgun Gothic" pitchFamily="34" charset="0"/>
+                <a:ea typeface="Malgun Gothic" pitchFamily="34" charset="-122"/>
+                <a:cs typeface="Malgun Gothic" pitchFamily="34" charset="-120"/>
+              </a:rPr>
+              <a:t>AI 씬의 승부처 = 실행 계층(런타임)</a:t>
+            </a:r>
+            <a:endParaRPr lang="en-US" sz="1200" dirty="0"/>
+          </a:p>
+        </p:txBody>
+      </p:sp>
+      <p:sp>
+        <p:nvSpPr>
+          <p:cNvPr id="22" name="Text 20"/>
+          <p:cNvSpPr/>
+          <p:nvPr/>
+        </p:nvSpPr>
+        <p:spPr>
+          <a:xfrm>
+            <a:off x="365760" y="1764792"/>
             <a:ext cx="3624986" cy="713232"/>
           </a:xfrm>
           <a:prstGeom prst="rect">
@@ -2651,7 +2690,7 @@
                 <a:ea typeface="Malgun Gothic" pitchFamily="34" charset="-122"/>
                 <a:cs typeface="Malgun Gothic" pitchFamily="34" charset="-120"/>
               </a:rPr>
-              <a:t>HW는 능력만 제공 — 데이터 배치·이동·연산 위치의 '결정'이 성능을 만들며, 이종 tier·근접연산 등장으로 결정 공간 폭발 → 결정 계층(런타임)의 비중 급증</a:t>
+              <a:t>배치·이동·스케줄링을 결정하는 실행 계층 — 업계 전체가 자체 런타임(TensorRT-LLM·ONNX Runtime·vLLM·SGLang)에 투자, CUDA 해자도 실리콘 아닌 SW 스택</a:t>
             </a:r>
             <a:endParaRPr lang="en-US" sz="1100" dirty="0"/>
           </a:p>
@@ -2659,7 +2698,7 @@
       </p:sp>
       <p:pic>
         <p:nvPicPr>
-          <p:cNvPr id="22" name="Image 0" descr="/home/user/architect/docs/mcr_assets/bg_decision.png">    </p:cNvPr>
+          <p:cNvPr id="23" name="Image 0" descr="/home/user/architect/docs/mcr_assets/bg_stack_runtime.png">    </p:cNvPr>
           <p:cNvPicPr>
             <a:picLocks noChangeAspect="1"/>
           </p:cNvPicPr>
@@ -2672,8 +2711,8 @@
         </p:blipFill>
         <p:spPr>
           <a:xfrm>
-            <a:off x="320040" y="2286000"/>
-            <a:ext cx="3716426" cy="1618488"/>
+            <a:off x="320040" y="2523744"/>
+            <a:ext cx="3716426" cy="1380744"/>
           </a:xfrm>
           <a:prstGeom prst="rect">
             <a:avLst/>
@@ -2682,13 +2721,52 @@
       </p:pic>
       <p:sp>
         <p:nvSpPr>
-          <p:cNvPr id="23" name="Text 20"/>
+          <p:cNvPr id="24" name="Text 21"/>
           <p:cNvSpPr/>
           <p:nvPr/>
         </p:nvSpPr>
         <p:spPr>
           <a:xfrm>
             <a:off x="365760" y="4069080"/>
+            <a:ext cx="3624986" cy="237744"/>
+          </a:xfrm>
+          <a:prstGeom prst="rect">
+            <a:avLst/>
+          </a:prstGeom>
+          <a:noFill/>
+          <a:ln/>
+        </p:spPr>
+        <p:txBody>
+          <a:bodyPr wrap="square" lIns="0" tIns="0" rIns="0" bIns="0" rtlCol="0" anchor="ctr"/>
+          <a:lstStyle/>
+          <a:p>
+            <a:pPr indent="0" marL="0">
+              <a:buNone/>
+            </a:pPr>
+            <a:r>
+              <a:rPr lang="en-US" sz="1200" b="1" dirty="0">
+                <a:solidFill>
+                  <a:srgbClr val="1F3864"/>
+                </a:solidFill>
+                <a:latin typeface="Malgun Gothic" pitchFamily="34" charset="0"/>
+                <a:ea typeface="Malgun Gothic" pitchFamily="34" charset="-122"/>
+                <a:cs typeface="Malgun Gothic" pitchFamily="34" charset="-120"/>
+              </a:rPr>
+              <a:t>같은 HW, 런타임만으로 갈린 성능</a:t>
+            </a:r>
+            <a:endParaRPr lang="en-US" sz="1200" dirty="0"/>
+          </a:p>
+        </p:txBody>
+      </p:sp>
+      <p:sp>
+        <p:nvSpPr>
+          <p:cNvPr id="25" name="Text 22"/>
+          <p:cNvSpPr/>
+          <p:nvPr/>
+        </p:nvSpPr>
+        <p:spPr>
+          <a:xfrm>
+            <a:off x="365760" y="4306824"/>
             <a:ext cx="3624986" cy="713232"/>
           </a:xfrm>
           <a:prstGeom prst="rect">
@@ -2717,7 +2795,7 @@
                 <a:ea typeface="Malgun Gothic" pitchFamily="34" charset="-122"/>
                 <a:cs typeface="Malgun Gothic" pitchFamily="34" charset="-120"/>
               </a:rPr>
-              <a:t>같은 HW에서 런타임만으로 처리량 2–4×(vLLM SOSP'23)·100×(FlexGen ICML'23) 격차 — HW 스펙은 상한일 뿐, 도달 성능은 런타임이 결정</a:t>
+              <a:t>런타임만으로 처리량 2–4×(vLLM SOSP'23)·100×(FlexGen ICML'23) 격차 — HW 스펙은 상한일 뿐, 도달 성능은 런타임이 결정</a:t>
             </a:r>
             <a:endParaRPr lang="en-US" sz="1100" dirty="0"/>
           </a:p>
@@ -2725,7 +2803,7 @@
       </p:sp>
       <p:pic>
         <p:nvPicPr>
-          <p:cNvPr id="24" name="Image 1" descr="/home/user/architect/docs/mcr_assets/bg_gap_evidence.png">    </p:cNvPr>
+          <p:cNvPr id="26" name="Image 1" descr="/home/user/architect/docs/mcr_assets/bg_gap_evidence.png">    </p:cNvPr>
           <p:cNvPicPr>
             <a:picLocks noChangeAspect="1"/>
           </p:cNvPicPr>
@@ -2738,8 +2816,8 @@
         </p:blipFill>
         <p:spPr>
           <a:xfrm>
-            <a:off x="320040" y="4828032"/>
-            <a:ext cx="3716426" cy="1618488"/>
+            <a:off x="320040" y="5065776"/>
+            <a:ext cx="3716426" cy="1380744"/>
           </a:xfrm>
           <a:prstGeom prst="rect">
             <a:avLst/>
@@ -2748,7 +2826,7 @@
       </p:pic>
       <p:sp>
         <p:nvSpPr>
-          <p:cNvPr id="25" name="Shape 21"/>
+          <p:cNvPr id="27" name="Shape 23"/>
           <p:cNvSpPr/>
           <p:nvPr/>
         </p:nvSpPr>
@@ -2768,7 +2846,7 @@
       </p:sp>
       <p:sp>
         <p:nvSpPr>
-          <p:cNvPr id="26" name="Text 22"/>
+          <p:cNvPr id="28" name="Text 24"/>
           <p:cNvSpPr/>
           <p:nvPr/>
         </p:nvSpPr>
@@ -2807,13 +2885,52 @@
       </p:sp>
       <p:sp>
         <p:nvSpPr>
-          <p:cNvPr id="27" name="Text 23"/>
+          <p:cNvPr id="29" name="Text 25"/>
           <p:cNvSpPr/>
           <p:nvPr/>
         </p:nvSpPr>
         <p:spPr>
           <a:xfrm>
             <a:off x="4283354" y="1527048"/>
+            <a:ext cx="3624986" cy="237744"/>
+          </a:xfrm>
+          <a:prstGeom prst="rect">
+            <a:avLst/>
+          </a:prstGeom>
+          <a:noFill/>
+          <a:ln/>
+        </p:spPr>
+        <p:txBody>
+          <a:bodyPr wrap="square" lIns="0" tIns="0" rIns="0" bIns="0" rtlCol="0" anchor="ctr"/>
+          <a:lstStyle/>
+          <a:p>
+            <a:pPr indent="0" marL="0">
+              <a:buNone/>
+            </a:pPr>
+            <a:r>
+              <a:rPr lang="en-US" sz="1200" b="1" dirty="0">
+                <a:solidFill>
+                  <a:srgbClr val="1F3864"/>
+                </a:solidFill>
+                <a:latin typeface="Malgun Gothic" pitchFamily="34" charset="0"/>
+                <a:ea typeface="Malgun Gothic" pitchFamily="34" charset="-122"/>
+                <a:cs typeface="Malgun Gothic" pitchFamily="34" charset="-120"/>
+              </a:rPr>
+              <a:t>GPU 중심 설계 — 단일 메모리 가정</a:t>
+            </a:r>
+            <a:endParaRPr lang="en-US" sz="1200" dirty="0"/>
+          </a:p>
+        </p:txBody>
+      </p:sp>
+      <p:sp>
+        <p:nvSpPr>
+          <p:cNvPr id="30" name="Text 26"/>
+          <p:cNvSpPr/>
+          <p:nvPr/>
+        </p:nvSpPr>
+        <p:spPr>
+          <a:xfrm>
+            <a:off x="4283354" y="1764792"/>
             <a:ext cx="3624986" cy="713232"/>
           </a:xfrm>
           <a:prstGeom prst="rect">
@@ -2842,7 +2959,7 @@
                 <a:ea typeface="Malgun Gothic" pitchFamily="34" charset="-122"/>
                 <a:cs typeface="Malgun Gothic" pitchFamily="34" charset="-120"/>
               </a:rPr>
-              <a:t>GPU 중심 설계: '연산=GPU, KV=HBM' 단일 메모리 가정 — 메모리는 GPU 부속물, PIM/PNM 표현 자리 없고 HBM 초과 시 성능 급락</a:t>
+              <a:t>'연산=GPU, KV=HBM' 가정 — 메모리는 GPU 부속물, PIM/PNM 표현 자리 없고 HBM 초과 시 성능 급락</a:t>
             </a:r>
             <a:endParaRPr lang="en-US" sz="1100" dirty="0"/>
           </a:p>
@@ -2850,7 +2967,7 @@
       </p:sp>
       <p:pic>
         <p:nvPicPr>
-          <p:cNvPr id="28" name="Image 2" descr="/home/user/architect/docs/mcr_assets/nec_missing.png">    </p:cNvPr>
+          <p:cNvPr id="31" name="Image 2" descr="/home/user/architect/docs/mcr_assets/nec_missing.png">    </p:cNvPr>
           <p:cNvPicPr>
             <a:picLocks noChangeAspect="1"/>
           </p:cNvPicPr>
@@ -2863,8 +2980,8 @@
         </p:blipFill>
         <p:spPr>
           <a:xfrm>
-            <a:off x="4237634" y="2286000"/>
-            <a:ext cx="3716426" cy="1618488"/>
+            <a:off x="4237634" y="2523744"/>
+            <a:ext cx="3716426" cy="1380744"/>
           </a:xfrm>
           <a:prstGeom prst="rect">
             <a:avLst/>
@@ -2873,13 +2990,52 @@
       </p:pic>
       <p:sp>
         <p:nvSpPr>
-          <p:cNvPr id="29" name="Text 24"/>
+          <p:cNvPr id="32" name="Text 27"/>
           <p:cNvSpPr/>
           <p:nvPr/>
         </p:nvSpPr>
         <p:spPr>
           <a:xfrm>
             <a:off x="4283354" y="4069080"/>
+            <a:ext cx="3624986" cy="237744"/>
+          </a:xfrm>
+          <a:prstGeom prst="rect">
+            <a:avLst/>
+          </a:prstGeom>
+          <a:noFill/>
+          <a:ln/>
+        </p:spPr>
+        <p:txBody>
+          <a:bodyPr wrap="square" lIns="0" tIns="0" rIns="0" bIns="0" rtlCol="0" anchor="ctr"/>
+          <a:lstStyle/>
+          <a:p>
+            <a:pPr indent="0" marL="0">
+              <a:buNone/>
+            </a:pPr>
+            <a:r>
+              <a:rPr lang="en-US" sz="1200" b="1" dirty="0">
+                <a:solidFill>
+                  <a:srgbClr val="1F3864"/>
+                </a:solidFill>
+                <a:latin typeface="Malgun Gothic" pitchFamily="34" charset="0"/>
+                <a:ea typeface="Malgun Gothic" pitchFamily="34" charset="-122"/>
+                <a:cs typeface="Malgun Gothic" pitchFamily="34" charset="-120"/>
+              </a:rPr>
+              <a:t>KV 계층의 등장, 그러나 수동 백엔드</a:t>
+            </a:r>
+            <a:endParaRPr lang="en-US" sz="1200" dirty="0"/>
+          </a:p>
+        </p:txBody>
+      </p:sp>
+      <p:sp>
+        <p:nvSpPr>
+          <p:cNvPr id="33" name="Text 28"/>
+          <p:cNvSpPr/>
+          <p:nvPr/>
+        </p:nvSpPr>
+        <p:spPr>
+          <a:xfrm>
+            <a:off x="4283354" y="4306824"/>
             <a:ext cx="3624986" cy="713232"/>
           </a:xfrm>
           <a:prstGeom prst="rect">
@@ -2916,7 +3072,7 @@
       </p:sp>
       <p:pic>
         <p:nvPicPr>
-          <p:cNvPr id="30" name="Image 3" descr="/home/user/architect/docs/mcr_assets/nec_kvlayer.png">    </p:cNvPr>
+          <p:cNvPr id="34" name="Image 3" descr="/home/user/architect/docs/mcr_assets/nec_kvlayer.png">    </p:cNvPr>
           <p:cNvPicPr>
             <a:picLocks noChangeAspect="1"/>
           </p:cNvPicPr>
@@ -2929,8 +3085,8 @@
         </p:blipFill>
         <p:spPr>
           <a:xfrm>
-            <a:off x="4237634" y="4828032"/>
-            <a:ext cx="3716426" cy="1618488"/>
+            <a:off x="4237634" y="5065776"/>
+            <a:ext cx="3716426" cy="1380744"/>
           </a:xfrm>
           <a:prstGeom prst="rect">
             <a:avLst/>
@@ -2939,7 +3095,7 @@
       </p:pic>
       <p:sp>
         <p:nvSpPr>
-          <p:cNvPr id="31" name="Shape 25"/>
+          <p:cNvPr id="35" name="Shape 29"/>
           <p:cNvSpPr/>
           <p:nvPr/>
         </p:nvSpPr>
@@ -2959,7 +3115,7 @@
       </p:sp>
       <p:sp>
         <p:nvSpPr>
-          <p:cNvPr id="32" name="Text 26"/>
+          <p:cNvPr id="36" name="Text 30"/>
           <p:cNvSpPr/>
           <p:nvPr/>
         </p:nvSpPr>
@@ -2998,13 +3154,52 @@
       </p:sp>
       <p:sp>
         <p:nvSpPr>
-          <p:cNvPr id="33" name="Text 27"/>
+          <p:cNvPr id="37" name="Text 31"/>
           <p:cNvSpPr/>
           <p:nvPr/>
         </p:nvSpPr>
         <p:spPr>
           <a:xfrm>
             <a:off x="8200949" y="1527048"/>
+            <a:ext cx="3624986" cy="237744"/>
+          </a:xfrm>
+          <a:prstGeom prst="rect">
+            <a:avLst/>
+          </a:prstGeom>
+          <a:noFill/>
+          <a:ln/>
+        </p:spPr>
+        <p:txBody>
+          <a:bodyPr wrap="square" lIns="0" tIns="0" rIns="0" bIns="0" rtlCol="0" anchor="ctr"/>
+          <a:lstStyle/>
+          <a:p>
+            <a:pPr indent="0" marL="0">
+              <a:buNone/>
+            </a:pPr>
+            <a:r>
+              <a:rPr lang="en-US" sz="1200" b="1" dirty="0">
+                <a:solidFill>
+                  <a:srgbClr val="1F3864"/>
+                </a:solidFill>
+                <a:latin typeface="Malgun Gothic" pitchFamily="34" charset="0"/>
+                <a:ea typeface="Malgun Gothic" pitchFamily="34" charset="-122"/>
+                <a:cs typeface="Malgun Gothic" pitchFamily="34" charset="-120"/>
+              </a:rPr>
+              <a:t>메모리를 1급 자원으로 — MCR</a:t>
+            </a:r>
+            <a:endParaRPr lang="en-US" sz="1200" dirty="0"/>
+          </a:p>
+        </p:txBody>
+      </p:sp>
+      <p:sp>
+        <p:nvSpPr>
+          <p:cNvPr id="38" name="Text 32"/>
+          <p:cNvSpPr/>
+          <p:nvPr/>
+        </p:nvSpPr>
+        <p:spPr>
+          <a:xfrm>
+            <a:off x="8200949" y="1764792"/>
             <a:ext cx="3624986" cy="713232"/>
           </a:xfrm>
           <a:prstGeom prst="rect">
@@ -3041,7 +3236,7 @@
       </p:sp>
       <p:pic>
         <p:nvPicPr>
-          <p:cNvPr id="34" name="Image 4" descr="/home/user/architect/docs/mcr_assets/nec_arch.png">    </p:cNvPr>
+          <p:cNvPr id="39" name="Image 4" descr="/home/user/architect/docs/mcr_assets/nec_arch.png">    </p:cNvPr>
           <p:cNvPicPr>
             <a:picLocks noChangeAspect="1"/>
           </p:cNvPicPr>
@@ -3054,8 +3249,8 @@
         </p:blipFill>
         <p:spPr>
           <a:xfrm>
-            <a:off x="8155229" y="2286000"/>
-            <a:ext cx="3716426" cy="1618488"/>
+            <a:off x="8155229" y="2523744"/>
+            <a:ext cx="3716426" cy="1380744"/>
           </a:xfrm>
           <a:prstGeom prst="rect">
             <a:avLst/>
@@ -3064,13 +3259,52 @@
       </p:pic>
       <p:sp>
         <p:nvSpPr>
-          <p:cNvPr id="35" name="Text 28"/>
+          <p:cNvPr id="40" name="Text 33"/>
           <p:cNvSpPr/>
           <p:nvPr/>
         </p:nvSpPr>
         <p:spPr>
           <a:xfrm>
             <a:off x="8200949" y="4069080"/>
+            <a:ext cx="3624986" cy="237744"/>
+          </a:xfrm>
+          <a:prstGeom prst="rect">
+            <a:avLst/>
+          </a:prstGeom>
+          <a:noFill/>
+          <a:ln/>
+        </p:spPr>
+        <p:txBody>
+          <a:bodyPr wrap="square" lIns="0" tIns="0" rIns="0" bIns="0" rtlCol="0" anchor="ctr"/>
+          <a:lstStyle/>
+          <a:p>
+            <a:pPr indent="0" marL="0">
+              <a:buNone/>
+            </a:pPr>
+            <a:r>
+              <a:rPr lang="en-US" sz="1200" b="1" dirty="0">
+                <a:solidFill>
+                  <a:srgbClr val="1F3864"/>
+                </a:solidFill>
+                <a:latin typeface="Malgun Gothic" pitchFamily="34" charset="0"/>
+                <a:ea typeface="Malgun Gothic" pitchFamily="34" charset="-122"/>
+                <a:cs typeface="Malgun Gothic" pitchFamily="34" charset="-120"/>
+              </a:rPr>
+              <a:t>레퍼런스 스택 · E2E 정량 증명</a:t>
+            </a:r>
+            <a:endParaRPr lang="en-US" sz="1200" dirty="0"/>
+          </a:p>
+        </p:txBody>
+      </p:sp>
+      <p:sp>
+        <p:nvSpPr>
+          <p:cNvPr id="41" name="Text 34"/>
+          <p:cNvSpPr/>
+          <p:nvPr/>
+        </p:nvSpPr>
+        <p:spPr>
+          <a:xfrm>
+            <a:off x="8200949" y="4306824"/>
             <a:ext cx="3624986" cy="713232"/>
           </a:xfrm>
           <a:prstGeom prst="rect">
@@ -3107,7 +3341,7 @@
       </p:sp>
       <p:pic>
         <p:nvPicPr>
-          <p:cNvPr id="36" name="Image 5" descr="/home/user/architect/docs/mcr_assets/nec_e2e.png">    </p:cNvPr>
+          <p:cNvPr id="42" name="Image 5" descr="/home/user/architect/docs/mcr_assets/nec_e2e.png">    </p:cNvPr>
           <p:cNvPicPr>
             <a:picLocks noChangeAspect="1"/>
           </p:cNvPicPr>
@@ -3120,8 +3354,8 @@
         </p:blipFill>
         <p:spPr>
           <a:xfrm>
-            <a:off x="8155229" y="4828032"/>
-            <a:ext cx="3716426" cy="1618488"/>
+            <a:off x="8155229" y="5065776"/>
+            <a:ext cx="3716426" cy="1380744"/>
           </a:xfrm>
           <a:prstGeom prst="rect">
             <a:avLst/>

</xml_diff>

<commit_message>
Background ⑤⑥: concrete GPU-runtime-limit visual and MCR difference
- ⑤ 상단: new diagram showing what a GPU-centric runtime actually
  breaks — KV overflowing HBM (preempt/recompute/swap) while
  DRAM/CXL/HBF tiers and PIM/PNM stay invisible to it; replaces the
  'reference stack missing' figure that didn't match the claim
- ⑤ 하단: '수동 백엔드' jargon rewritten in plain terms (넣고
  꺼내기만 하는 보관 계층 — tier 선택·근접 연산 판단 없음)
- ⑥ 상단: replaced abstract '1급 자원' phrasing with the concrete
  decisions (SLO-aware hot/warm/cold tier placement, compute pushdown
  to PIM, cross-session reuse) and a 4-row comparison figure of
  today's runtimes vs MCR

Co-Authored-By: Claude Fable 5 <noreply@anthropic.com>
Claude-Session: https://claude.ai/code/session_01LyTRzLdXE69fgJZWPU6Yf7
</commit_message>
<xml_diff>
--- a/docs/mcr_background_2p.pptx
+++ b/docs/mcr_background_2p.pptx
@@ -2916,7 +2916,7 @@
                 <a:ea typeface="Malgun Gothic" pitchFamily="34" charset="-122"/>
                 <a:cs typeface="Malgun Gothic" pitchFamily="34" charset="-120"/>
               </a:rPr>
-              <a:t>GPU 중심 설계 — 단일 메모리 가정</a:t>
+              <a:t>GPU 중심 설계 — 메모리는 부속물</a:t>
             </a:r>
             <a:endParaRPr lang="en-US" sz="1200" dirty="0"/>
           </a:p>
@@ -2959,7 +2959,7 @@
                 <a:ea typeface="Malgun Gothic" pitchFamily="34" charset="-122"/>
                 <a:cs typeface="Malgun Gothic" pitchFamily="34" charset="-120"/>
               </a:rPr>
-              <a:t>'연산=GPU, KV=HBM' 가정 — 메모리는 GPU 부속물, PIM/PNM 표현 자리 없고 HBM 초과 시 성능 급락</a:t>
+              <a:t>'연산=GPU, KV=HBM' 가정 — KV가 HBM을 넘는 순간 선점·재계산·스왑으로 성능 급락, DRAM·CXL·HBF tier와 PIM/PNM은 런타임에 보이지도 않음</a:t>
             </a:r>
             <a:endParaRPr lang="en-US" sz="1100" dirty="0"/>
           </a:p>
@@ -2967,7 +2967,7 @@
       </p:sp>
       <p:pic>
         <p:nvPicPr>
-          <p:cNvPr id="31" name="Image 2" descr="/home/user/architect/docs/mcr_assets/nec_missing.png">    </p:cNvPr>
+          <p:cNvPr id="31" name="Image 2" descr="/home/user/architect/docs/mcr_assets/nec_gpu_limit.png">    </p:cNvPr>
           <p:cNvPicPr>
             <a:picLocks noChangeAspect="1"/>
           </p:cNvPicPr>
@@ -3021,7 +3021,7 @@
                 <a:ea typeface="Malgun Gothic" pitchFamily="34" charset="-122"/>
                 <a:cs typeface="Malgun Gothic" pitchFamily="34" charset="-120"/>
               </a:rPr>
-              <a:t>KV 계층의 등장, 그러나 수동 백엔드</a:t>
+              <a:t>KV를 내리는 계층도 '넣고 꺼내기'뿐</a:t>
             </a:r>
             <a:endParaRPr lang="en-US" sz="1200" dirty="0"/>
           </a:p>
@@ -3064,7 +3064,7 @@
                 <a:ea typeface="Malgun Gothic" pitchFamily="34" charset="-122"/>
                 <a:cs typeface="Malgun Gothic" pitchFamily="34" charset="-120"/>
               </a:rPr>
-              <a:t>KV를 밖으로 내리는 계층(LMCache 등)도 CPU RAM·SSD 등 commodity 저장소의 수동 백엔드 — 디바이스 특성 인지 배치·근접 연산 없음</a:t>
+              <a:t>LMCache 등이 KV를 CPU RAM·SSD로 내려 보관하지만 하는 일은 넣고 꺼내기가 전부 — 어떤 KV를 어느 tier에 둘지, 연산을 데이터 쪽으로 보낼지는 판단하지 못함</a:t>
             </a:r>
             <a:endParaRPr lang="en-US" sz="1100" dirty="0"/>
           </a:p>
@@ -3185,7 +3185,7 @@
                 <a:ea typeface="Malgun Gothic" pitchFamily="34" charset="-122"/>
                 <a:cs typeface="Malgun Gothic" pitchFamily="34" charset="-120"/>
               </a:rPr>
-              <a:t>메모리를 1급 자원으로 — MCR</a:t>
+              <a:t>기존 런타임과 다른 점 — 결정을 내린다</a:t>
             </a:r>
             <a:endParaRPr lang="en-US" sz="1200" dirty="0"/>
           </a:p>
@@ -3228,7 +3228,7 @@
                 <a:ea typeface="Malgun Gothic" pitchFamily="34" charset="-122"/>
                 <a:cs typeface="Malgun Gothic" pitchFamily="34" charset="-120"/>
               </a:rPr>
-              <a:t>자사 포트폴리오를 1급 자원으로 — 데이터 배치·이동·압축·재사용과 연산 배치를 SLO 기준 조율하는 MCR(Memory-Centric Runtime)</a:t>
+              <a:t>요청 SLO 기준으로 hot KV는 HBM·warm은 CXL·cold는 압축해 flash에 배치하고, attention 연산은 PIM으로 보내 이동 자체를 절감 — '밀려나면 내리는' 기존 방식과의 차이</a:t>
             </a:r>
             <a:endParaRPr lang="en-US" sz="1100" dirty="0"/>
           </a:p>
@@ -3236,7 +3236,7 @@
       </p:sp>
       <p:pic>
         <p:nvPicPr>
-          <p:cNvPr id="39" name="Image 4" descr="/home/user/architect/docs/mcr_assets/nec_arch.png">    </p:cNvPr>
+          <p:cNvPr id="39" name="Image 4" descr="/home/user/architect/docs/mcr_assets/nec_mcr_diff.png">    </p:cNvPr>
           <p:cNvPicPr>
             <a:picLocks noChangeAspect="1"/>
           </p:cNvPicPr>

</xml_diff>

<commit_message>
Background ④: preempt the 'what about compilation?' objection
- ④ 하단 rephrased: gains came from memory management / placement
  policy with no faster kernels — an axis independent of compilation;
  chart title updated to match
- ④ 상단 stack diagram: footnote naming the two runtime levers
  (kernels & compilation vs dynamic resource management) and marking
  which one this project takes

Co-Authored-By: Claude Fable 5 <noreply@anthropic.com>
Claude-Session: https://claude.ai/code/session_01LyTRzLdXE69fgJZWPU6Yf7
</commit_message>
<xml_diff>
--- a/docs/mcr_background_2p.pptx
+++ b/docs/mcr_background_2p.pptx
@@ -2752,7 +2752,7 @@
                 <a:ea typeface="Malgun Gothic" pitchFamily="34" charset="-122"/>
                 <a:cs typeface="Malgun Gothic" pitchFamily="34" charset="-120"/>
               </a:rPr>
-              <a:t>같은 HW, 런타임만으로 갈린 성능</a:t>
+              <a:t>같은 HW, 관리 정책만으로 갈린 성능</a:t>
             </a:r>
             <a:endParaRPr lang="en-US" sz="1200" dirty="0"/>
           </a:p>
@@ -2795,7 +2795,7 @@
                 <a:ea typeface="Malgun Gothic" pitchFamily="34" charset="-122"/>
                 <a:cs typeface="Malgun Gothic" pitchFamily="34" charset="-120"/>
               </a:rPr>
-              <a:t>런타임만으로 처리량 2–4×(vLLM SOSP'23)·100×(FlexGen ICML'23) 격차 — HW 스펙은 상한일 뿐, 도달 성능은 런타임이 결정</a:t>
+              <a:t>커널을 빠르게 한 게 아니라 메모리 관리(vLLM, paging)·배치 정책(FlexGen, offloading)만 바꿔 2–4×·100× 격차 — 컴파일 축과 독립인 동적 자원 관리 축의 지렛대</a:t>
             </a:r>
             <a:endParaRPr lang="en-US" sz="1100" dirty="0"/>
           </a:p>

</xml_diff>